<commit_message>
feat: grafo per-trial su EEG_08/09/10 + callout Q&A Bomatter 2025 su slide 9
- EEG_08/09: rimosso PCC medio condiviso, ogni trial costruisce il proprio
  edge_index da PCC calcolato su quel trial (pcc_to_edge_index)
- EEG_10: stesso approccio per iperspigoli (pcc_to_hyperedge_index_trial),
  make_hypergraph_splits non richiede piu hyperedge_index statico
- Totale grafi dataset: 110 parole x ~5 trial x n_soggetti (ognuno unico)
- PPTX slide 9: aggiunto callout Q&A con riferimento a Bomatter & Gouk 2025
  (NeurIPS) sui >200 soggetti necessari per cross-subject EEG robusto

Co-Authored-By: Claude Sonnet 4.6 <noreply@anthropic.com>
</commit_message>
<xml_diff>
--- a/docs/presentations/presentation_stato_lavori_apr2026.pptx
+++ b/docs/presentations/presentation_stato_lavori_apr2026.pptx
@@ -17901,6 +17901,121 @@
           </a:p>
         </p:txBody>
       </p:sp>
+      <p:sp>
+        <p:nvSpPr>
+          <p:cNvPr id="16" name="QABg"/>
+          <p:cNvSpPr/>
+          <p:nvPr/>
+        </p:nvSpPr>
+        <p:spPr>
+          <a:xfrm>
+            <a:off x="320000" y="4290000"/>
+            <a:ext cx="8504000" cy="690000"/>
+          </a:xfrm>
+          <a:prstGeom prst="rect">
+            <a:avLst/>
+          </a:prstGeom>
+          <a:solidFill>
+            <a:srgbClr val="EEF2FA"/>
+          </a:solidFill>
+          <a:ln w="19050">
+            <a:solidFill>
+              <a:srgbClr val="1E2761"/>
+            </a:solidFill>
+            <a:prstDash val="dash"/>
+          </a:ln>
+        </p:spPr>
+      </p:sp>
+      <p:sp>
+        <p:nvSpPr>
+          <p:cNvPr id="17" name="QAAcc"/>
+          <p:cNvSpPr/>
+          <p:nvPr/>
+        </p:nvSpPr>
+        <p:spPr>
+          <a:xfrm>
+            <a:off x="320000" y="4290000"/>
+            <a:ext cx="30000" cy="690000"/>
+          </a:xfrm>
+          <a:prstGeom prst="rect">
+            <a:avLst/>
+          </a:prstGeom>
+          <a:solidFill>
+            <a:srgbClr val="F0AD4E"/>
+          </a:solidFill>
+          <a:ln w="0">
+            <a:noFill/>
+          </a:ln>
+        </p:spPr>
+      </p:sp>
+      <p:sp>
+        <p:nvSpPr>
+          <p:cNvPr id="18" name="QATxt"/>
+          <p:cNvSpPr/>
+          <p:nvPr/>
+        </p:nvSpPr>
+        <p:spPr>
+          <a:xfrm>
+            <a:off x="420000" y="4310000"/>
+            <a:ext cx="8254000" cy="650000"/>
+          </a:xfrm>
+          <a:prstGeom prst="rect">
+            <a:avLst/>
+          </a:prstGeom>
+          <a:noFill/>
+          <a:ln/>
+        </p:spPr>
+        <p:txBody>
+          <a:bodyPr wrap="square" rtlCol="0" anchor="t"/>
+          <a:lstStyle/>
+          <a:p>
+            <a:pPr algn="l" indent="0" marL="0">
+              <a:buNone/>
+            </a:pPr>
+            <a:r>
+              <a:rPr lang="it-IT" sz="1000" b="1" dirty="0">
+                <a:solidFill>
+                  <a:srgbClr val="856404"/>
+                </a:solidFill>
+                <a:latin typeface="Calibri" pitchFamily="34" charset="0"/>
+              </a:rPr>
+              <a:t>Q: 70 soggetti sono sufficienti per cross-subject?  </a:t>
+            </a:r>
+            <a:r>
+              <a:rPr lang="it-IT" sz="1000" i="1" dirty="0">
+                <a:solidFill>
+                  <a:srgbClr val="555555"/>
+                </a:solidFill>
+                <a:latin typeface="Calibri" pitchFamily="34" charset="0"/>
+              </a:rPr>
+              <a:t>Bomatter et al. 2025 (NeurIPS) dimostrano empiricamente che servono &gt;200 soggetti per generalizzazione cross-subject robusta in EEG.</a:t>
+            </a:r>
+          </a:p>
+          <a:p>
+            <a:pPr algn="l" indent="0" marL="0">
+              <a:buNone/>
+            </a:pPr>
+            <a:r>
+              <a:rPr lang="it-IT" sz="1000" b="1" dirty="0">
+                <a:solidFill>
+                  <a:srgbClr val="1E2761"/>
+                </a:solidFill>
+                <a:latin typeface="Calibri" pitchFamily="34" charset="0"/>
+              </a:rPr>
+              <a:t>A:  </a:t>
+            </a:r>
+            <a:r>
+              <a:rPr lang="it-IT" sz="1000" dirty="0">
+                <a:solidFill>
+                  <a:srgbClr val="333333"/>
+                </a:solidFill>
+                <a:latin typeface="Calibri" pitchFamily="34" charset="0"/>
+              </a:rPr>
+              <a:t>70 soggetti e il limite inferiore — limite strutturale del dataset, non dell'architettura. Stessa conclusione di FAST 2025 (57 sogg., +6.9% chance). Risultato onesto, non un fallimento del modello.</a:t>
+            </a:r>
+          </a:p>
+        </p:txBody>
+      </p:sp>
     </p:spTree>
   </p:cSld>
   <p:clrMapOvr>

</xml_diff>